<commit_message>
UPDATE FINAL PROJECT AI
</commit_message>
<xml_diff>
--- a/powerbi/P1.pptx
+++ b/powerbi/P1.pptx
@@ -462,7 +462,7 @@
           <a:p>
             <a:fld id="{212FFC1C-B776-4273-BF93-37B8C48E58C8}" type="datetimeFigureOut">
               <a:rPr lang="es-CO" smtClean="0"/>
-              <a:t>10/04/2026</a:t>
+              <a:t>2/06/2026</a:t>
             </a:fld>
             <a:endParaRPr lang="es-CO"/>
           </a:p>
@@ -632,7 +632,7 @@
           <a:p>
             <a:fld id="{212FFC1C-B776-4273-BF93-37B8C48E58C8}" type="datetimeFigureOut">
               <a:rPr lang="es-CO" smtClean="0"/>
-              <a:t>10/04/2026</a:t>
+              <a:t>2/06/2026</a:t>
             </a:fld>
             <a:endParaRPr lang="es-CO"/>
           </a:p>
@@ -812,7 +812,7 @@
           <a:p>
             <a:fld id="{212FFC1C-B776-4273-BF93-37B8C48E58C8}" type="datetimeFigureOut">
               <a:rPr lang="es-CO" smtClean="0"/>
-              <a:t>10/04/2026</a:t>
+              <a:t>2/06/2026</a:t>
             </a:fld>
             <a:endParaRPr lang="es-CO"/>
           </a:p>
@@ -982,7 +982,7 @@
           <a:p>
             <a:fld id="{212FFC1C-B776-4273-BF93-37B8C48E58C8}" type="datetimeFigureOut">
               <a:rPr lang="es-CO" smtClean="0"/>
-              <a:t>10/04/2026</a:t>
+              <a:t>2/06/2026</a:t>
             </a:fld>
             <a:endParaRPr lang="es-CO"/>
           </a:p>
@@ -1228,7 +1228,7 @@
           <a:p>
             <a:fld id="{212FFC1C-B776-4273-BF93-37B8C48E58C8}" type="datetimeFigureOut">
               <a:rPr lang="es-CO" smtClean="0"/>
-              <a:t>10/04/2026</a:t>
+              <a:t>2/06/2026</a:t>
             </a:fld>
             <a:endParaRPr lang="es-CO"/>
           </a:p>
@@ -1460,7 +1460,7 @@
           <a:p>
             <a:fld id="{212FFC1C-B776-4273-BF93-37B8C48E58C8}" type="datetimeFigureOut">
               <a:rPr lang="es-CO" smtClean="0"/>
-              <a:t>10/04/2026</a:t>
+              <a:t>2/06/2026</a:t>
             </a:fld>
             <a:endParaRPr lang="es-CO"/>
           </a:p>
@@ -1827,7 +1827,7 @@
           <a:p>
             <a:fld id="{212FFC1C-B776-4273-BF93-37B8C48E58C8}" type="datetimeFigureOut">
               <a:rPr lang="es-CO" smtClean="0"/>
-              <a:t>10/04/2026</a:t>
+              <a:t>2/06/2026</a:t>
             </a:fld>
             <a:endParaRPr lang="es-CO"/>
           </a:p>
@@ -1945,7 +1945,7 @@
           <a:p>
             <a:fld id="{212FFC1C-B776-4273-BF93-37B8C48E58C8}" type="datetimeFigureOut">
               <a:rPr lang="es-CO" smtClean="0"/>
-              <a:t>10/04/2026</a:t>
+              <a:t>2/06/2026</a:t>
             </a:fld>
             <a:endParaRPr lang="es-CO"/>
           </a:p>
@@ -2040,7 +2040,7 @@
           <a:p>
             <a:fld id="{212FFC1C-B776-4273-BF93-37B8C48E58C8}" type="datetimeFigureOut">
               <a:rPr lang="es-CO" smtClean="0"/>
-              <a:t>10/04/2026</a:t>
+              <a:t>2/06/2026</a:t>
             </a:fld>
             <a:endParaRPr lang="es-CO"/>
           </a:p>
@@ -2317,7 +2317,7 @@
           <a:p>
             <a:fld id="{212FFC1C-B776-4273-BF93-37B8C48E58C8}" type="datetimeFigureOut">
               <a:rPr lang="es-CO" smtClean="0"/>
-              <a:t>10/04/2026</a:t>
+              <a:t>2/06/2026</a:t>
             </a:fld>
             <a:endParaRPr lang="es-CO"/>
           </a:p>
@@ -2574,7 +2574,7 @@
           <a:p>
             <a:fld id="{212FFC1C-B776-4273-BF93-37B8C48E58C8}" type="datetimeFigureOut">
               <a:rPr lang="es-CO" smtClean="0"/>
-              <a:t>10/04/2026</a:t>
+              <a:t>2/06/2026</a:t>
             </a:fld>
             <a:endParaRPr lang="es-CO"/>
           </a:p>
@@ -2787,7 +2787,7 @@
           <a:p>
             <a:fld id="{212FFC1C-B776-4273-BF93-37B8C48E58C8}" type="datetimeFigureOut">
               <a:rPr lang="es-CO" smtClean="0"/>
-              <a:t>10/04/2026</a:t>
+              <a:t>2/06/2026</a:t>
             </a:fld>
             <a:endParaRPr lang="es-CO"/>
           </a:p>
@@ -3484,149 +3484,6 @@
       </p:grpSp>
       <p:sp>
         <p:nvSpPr>
-          <p:cNvPr id="56" name="Rectángulo: esquinas redondeadas 55">
-            <a:extLst>
-              <a:ext uri="{FF2B5EF4-FFF2-40B4-BE49-F238E27FC236}">
-                <a16:creationId xmlns:a16="http://schemas.microsoft.com/office/drawing/2014/main" id="{8C747452-BD37-15D7-CDE7-35E147CE628D}"/>
-              </a:ext>
-            </a:extLst>
-          </p:cNvPr>
-          <p:cNvSpPr/>
-          <p:nvPr/>
-        </p:nvSpPr>
-        <p:spPr>
-          <a:xfrm>
-            <a:off x="15115266" y="4312457"/>
-            <a:ext cx="5153934" cy="3086545"/>
-          </a:xfrm>
-          <a:prstGeom prst="roundRect">
-            <a:avLst>
-              <a:gd name="adj" fmla="val 7796"/>
-            </a:avLst>
-          </a:prstGeom>
-          <a:gradFill>
-            <a:gsLst>
-              <a:gs pos="0">
-                <a:srgbClr val="FFFFFF"/>
-              </a:gs>
-              <a:gs pos="100000">
-                <a:srgbClr val="F6F6F6"/>
-              </a:gs>
-            </a:gsLst>
-            <a:lin ang="5400000" scaled="1"/>
-          </a:gradFill>
-          <a:ln>
-            <a:noFill/>
-          </a:ln>
-          <a:effectLst>
-            <a:outerShdw blurRad="190500" dist="190500" dir="2700000" algn="tl" rotWithShape="0">
-              <a:schemeClr val="tx1">
-                <a:lumMod val="50000"/>
-                <a:lumOff val="50000"/>
-                <a:alpha val="40000"/>
-              </a:schemeClr>
-            </a:outerShdw>
-          </a:effectLst>
-        </p:spPr>
-        <p:style>
-          <a:lnRef idx="2">
-            <a:schemeClr val="accent1">
-              <a:shade val="15000"/>
-            </a:schemeClr>
-          </a:lnRef>
-          <a:fillRef idx="1">
-            <a:schemeClr val="accent1"/>
-          </a:fillRef>
-          <a:effectRef idx="0">
-            <a:schemeClr val="accent1"/>
-          </a:effectRef>
-          <a:fontRef idx="minor">
-            <a:schemeClr val="lt1"/>
-          </a:fontRef>
-        </p:style>
-        <p:txBody>
-          <a:bodyPr rtlCol="0" anchor="ctr"/>
-          <a:lstStyle/>
-          <a:p>
-            <a:pPr algn="ctr"/>
-            <a:endParaRPr lang="es-CO" sz="1114" dirty="0"/>
-          </a:p>
-        </p:txBody>
-      </p:sp>
-      <p:sp>
-        <p:nvSpPr>
-          <p:cNvPr id="62" name="Rectángulo: esquinas redondeadas 61">
-            <a:extLst>
-              <a:ext uri="{FF2B5EF4-FFF2-40B4-BE49-F238E27FC236}">
-                <a16:creationId xmlns:a16="http://schemas.microsoft.com/office/drawing/2014/main" id="{F5FB51C8-C616-AC0B-876C-5C25C7D4E389}"/>
-              </a:ext>
-            </a:extLst>
-          </p:cNvPr>
-          <p:cNvSpPr/>
-          <p:nvPr/>
-        </p:nvSpPr>
-        <p:spPr>
-          <a:xfrm>
-            <a:off x="15135308" y="1971230"/>
-            <a:ext cx="5153934" cy="2024949"/>
-          </a:xfrm>
-          <a:prstGeom prst="roundRect">
-            <a:avLst/>
-          </a:prstGeom>
-          <a:gradFill>
-            <a:gsLst>
-              <a:gs pos="0">
-                <a:srgbClr val="FFFFFF"/>
-              </a:gs>
-              <a:gs pos="100000">
-                <a:srgbClr val="F6F6F6"/>
-              </a:gs>
-            </a:gsLst>
-            <a:lin ang="5400000" scaled="1"/>
-          </a:gradFill>
-          <a:ln>
-            <a:noFill/>
-          </a:ln>
-          <a:effectLst>
-            <a:outerShdw blurRad="190500" dist="190500" dir="2700000" algn="tl" rotWithShape="0">
-              <a:schemeClr val="tx1">
-                <a:lumMod val="50000"/>
-                <a:lumOff val="50000"/>
-                <a:alpha val="40000"/>
-              </a:schemeClr>
-            </a:outerShdw>
-          </a:effectLst>
-        </p:spPr>
-        <p:style>
-          <a:lnRef idx="2">
-            <a:schemeClr val="accent1">
-              <a:shade val="15000"/>
-            </a:schemeClr>
-          </a:lnRef>
-          <a:fillRef idx="1">
-            <a:schemeClr val="accent1"/>
-          </a:fillRef>
-          <a:effectRef idx="0">
-            <a:schemeClr val="accent1"/>
-          </a:effectRef>
-          <a:fontRef idx="minor">
-            <a:schemeClr val="lt1"/>
-          </a:fontRef>
-        </p:style>
-        <p:txBody>
-          <a:bodyPr rtlCol="0" anchor="ctr"/>
-          <a:lstStyle/>
-          <a:p>
-            <a:pPr algn="ctr"/>
-            <a:r>
-              <a:rPr lang="es-CO" sz="1114" dirty="0"/>
-              <a:t>v</a:t>
-            </a:r>
-          </a:p>
-        </p:txBody>
-      </p:sp>
-      <p:sp>
-        <p:nvSpPr>
           <p:cNvPr id="1027" name="Rectángulo: esquinas redondeadas 1026">
             <a:extLst>
               <a:ext uri="{FF2B5EF4-FFF2-40B4-BE49-F238E27FC236}">
@@ -3639,150 +3496,8 @@
         </p:nvSpPr>
         <p:spPr>
           <a:xfrm>
-            <a:off x="2480830" y="4312457"/>
-            <a:ext cx="12335995" cy="2673728"/>
-          </a:xfrm>
-          <a:prstGeom prst="roundRect">
-            <a:avLst>
-              <a:gd name="adj" fmla="val 10356"/>
-            </a:avLst>
-          </a:prstGeom>
-          <a:gradFill>
-            <a:gsLst>
-              <a:gs pos="0">
-                <a:srgbClr val="FFFFFF"/>
-              </a:gs>
-              <a:gs pos="100000">
-                <a:srgbClr val="F6F6F6"/>
-              </a:gs>
-            </a:gsLst>
-            <a:lin ang="5400000" scaled="1"/>
-          </a:gradFill>
-          <a:ln>
-            <a:noFill/>
-          </a:ln>
-          <a:effectLst>
-            <a:outerShdw blurRad="190500" dist="190500" dir="2700000" algn="tl" rotWithShape="0">
-              <a:schemeClr val="tx1">
-                <a:lumMod val="50000"/>
-                <a:lumOff val="50000"/>
-                <a:alpha val="40000"/>
-              </a:schemeClr>
-            </a:outerShdw>
-          </a:effectLst>
-        </p:spPr>
-        <p:style>
-          <a:lnRef idx="2">
-            <a:schemeClr val="accent1">
-              <a:shade val="15000"/>
-            </a:schemeClr>
-          </a:lnRef>
-          <a:fillRef idx="1">
-            <a:schemeClr val="accent1"/>
-          </a:fillRef>
-          <a:effectRef idx="0">
-            <a:schemeClr val="accent1"/>
-          </a:effectRef>
-          <a:fontRef idx="minor">
-            <a:schemeClr val="lt1"/>
-          </a:fontRef>
-        </p:style>
-        <p:txBody>
-          <a:bodyPr rtlCol="0" anchor="ctr"/>
-          <a:lstStyle/>
-          <a:p>
-            <a:pPr algn="ctr"/>
-            <a:endParaRPr lang="es-CO" sz="1114" dirty="0"/>
-          </a:p>
-        </p:txBody>
-      </p:sp>
-      <p:sp>
-        <p:nvSpPr>
-          <p:cNvPr id="1030" name="Rectángulo: esquinas redondeadas 1029">
-            <a:extLst>
-              <a:ext uri="{FF2B5EF4-FFF2-40B4-BE49-F238E27FC236}">
-                <a16:creationId xmlns:a16="http://schemas.microsoft.com/office/drawing/2014/main" id="{08AB3694-0E20-F93C-EAC2-BC0EFB8760E8}"/>
-              </a:ext>
-            </a:extLst>
-          </p:cNvPr>
-          <p:cNvSpPr/>
-          <p:nvPr/>
-        </p:nvSpPr>
-        <p:spPr>
-          <a:xfrm>
-            <a:off x="2480830" y="1920518"/>
-            <a:ext cx="4224771" cy="2024949"/>
-          </a:xfrm>
-          <a:prstGeom prst="roundRect">
-            <a:avLst>
-              <a:gd name="adj" fmla="val 10356"/>
-            </a:avLst>
-          </a:prstGeom>
-          <a:gradFill>
-            <a:gsLst>
-              <a:gs pos="0">
-                <a:srgbClr val="FFFFFF"/>
-              </a:gs>
-              <a:gs pos="100000">
-                <a:srgbClr val="F6F6F6"/>
-              </a:gs>
-            </a:gsLst>
-            <a:lin ang="5400000" scaled="1"/>
-          </a:gradFill>
-          <a:ln>
-            <a:noFill/>
-          </a:ln>
-          <a:effectLst>
-            <a:outerShdw blurRad="190500" dist="190500" dir="2700000" algn="tl" rotWithShape="0">
-              <a:schemeClr val="tx1">
-                <a:lumMod val="50000"/>
-                <a:lumOff val="50000"/>
-                <a:alpha val="40000"/>
-              </a:schemeClr>
-            </a:outerShdw>
-          </a:effectLst>
-        </p:spPr>
-        <p:style>
-          <a:lnRef idx="2">
-            <a:schemeClr val="accent1">
-              <a:shade val="15000"/>
-            </a:schemeClr>
-          </a:lnRef>
-          <a:fillRef idx="1">
-            <a:schemeClr val="accent1"/>
-          </a:fillRef>
-          <a:effectRef idx="0">
-            <a:schemeClr val="accent1"/>
-          </a:effectRef>
-          <a:fontRef idx="minor">
-            <a:schemeClr val="lt1"/>
-          </a:fontRef>
-        </p:style>
-        <p:txBody>
-          <a:bodyPr rtlCol="0" anchor="ctr"/>
-          <a:lstStyle/>
-          <a:p>
-            <a:pPr algn="ctr"/>
-            <a:endParaRPr lang="es-CO" sz="1114" dirty="0"/>
-          </a:p>
-        </p:txBody>
-      </p:sp>
-      <p:sp>
-        <p:nvSpPr>
-          <p:cNvPr id="1031" name="Rectángulo: esquinas redondeadas 1030">
-            <a:extLst>
-              <a:ext uri="{FF2B5EF4-FFF2-40B4-BE49-F238E27FC236}">
-                <a16:creationId xmlns:a16="http://schemas.microsoft.com/office/drawing/2014/main" id="{91B256DE-DD44-DE64-2856-20ADF8D6EFBC}"/>
-              </a:ext>
-            </a:extLst>
-          </p:cNvPr>
-          <p:cNvSpPr/>
-          <p:nvPr/>
-        </p:nvSpPr>
-        <p:spPr>
-          <a:xfrm>
-            <a:off x="7024082" y="1936179"/>
-            <a:ext cx="3737131" cy="2024949"/>
+            <a:off x="2480830" y="1894796"/>
+            <a:ext cx="17668627" cy="3820204"/>
           </a:xfrm>
           <a:prstGeom prst="roundRect">
             <a:avLst>
@@ -3978,148 +3693,6 @@
       </p:sp>
       <p:sp>
         <p:nvSpPr>
-          <p:cNvPr id="1039" name="Rectángulo: esquinas redondeadas 1038">
-            <a:extLst>
-              <a:ext uri="{FF2B5EF4-FFF2-40B4-BE49-F238E27FC236}">
-                <a16:creationId xmlns:a16="http://schemas.microsoft.com/office/drawing/2014/main" id="{AC038B68-B5C7-5CA1-1BC6-ABFC941C766A}"/>
-              </a:ext>
-            </a:extLst>
-          </p:cNvPr>
-          <p:cNvSpPr/>
-          <p:nvPr/>
-        </p:nvSpPr>
-        <p:spPr>
-          <a:xfrm>
-            <a:off x="15115266" y="7715281"/>
-            <a:ext cx="5153934" cy="3086545"/>
-          </a:xfrm>
-          <a:prstGeom prst="roundRect">
-            <a:avLst>
-              <a:gd name="adj" fmla="val 7796"/>
-            </a:avLst>
-          </a:prstGeom>
-          <a:gradFill>
-            <a:gsLst>
-              <a:gs pos="0">
-                <a:srgbClr val="FFFFFF"/>
-              </a:gs>
-              <a:gs pos="100000">
-                <a:srgbClr val="F6F6F6"/>
-              </a:gs>
-            </a:gsLst>
-            <a:lin ang="5400000" scaled="1"/>
-          </a:gradFill>
-          <a:ln>
-            <a:noFill/>
-          </a:ln>
-          <a:effectLst>
-            <a:outerShdw blurRad="190500" dist="190500" dir="2700000" algn="tl" rotWithShape="0">
-              <a:schemeClr val="tx1">
-                <a:lumMod val="50000"/>
-                <a:lumOff val="50000"/>
-                <a:alpha val="40000"/>
-              </a:schemeClr>
-            </a:outerShdw>
-          </a:effectLst>
-        </p:spPr>
-        <p:style>
-          <a:lnRef idx="2">
-            <a:schemeClr val="accent1">
-              <a:shade val="15000"/>
-            </a:schemeClr>
-          </a:lnRef>
-          <a:fillRef idx="1">
-            <a:schemeClr val="accent1"/>
-          </a:fillRef>
-          <a:effectRef idx="0">
-            <a:schemeClr val="accent1"/>
-          </a:effectRef>
-          <a:fontRef idx="minor">
-            <a:schemeClr val="lt1"/>
-          </a:fontRef>
-        </p:style>
-        <p:txBody>
-          <a:bodyPr rtlCol="0" anchor="ctr"/>
-          <a:lstStyle/>
-          <a:p>
-            <a:pPr algn="ctr"/>
-            <a:endParaRPr lang="es-CO" sz="1114" dirty="0"/>
-          </a:p>
-        </p:txBody>
-      </p:sp>
-      <p:sp>
-        <p:nvSpPr>
-          <p:cNvPr id="1042" name="Rectángulo: esquinas redondeadas 1041">
-            <a:extLst>
-              <a:ext uri="{FF2B5EF4-FFF2-40B4-BE49-F238E27FC236}">
-                <a16:creationId xmlns:a16="http://schemas.microsoft.com/office/drawing/2014/main" id="{5ED2494D-EFC8-16BE-6988-083017015BCD}"/>
-              </a:ext>
-            </a:extLst>
-          </p:cNvPr>
-          <p:cNvSpPr/>
-          <p:nvPr/>
-        </p:nvSpPr>
-        <p:spPr>
-          <a:xfrm>
-            <a:off x="11079694" y="1920518"/>
-            <a:ext cx="3737131" cy="2024949"/>
-          </a:xfrm>
-          <a:prstGeom prst="roundRect">
-            <a:avLst>
-              <a:gd name="adj" fmla="val 10356"/>
-            </a:avLst>
-          </a:prstGeom>
-          <a:gradFill>
-            <a:gsLst>
-              <a:gs pos="0">
-                <a:srgbClr val="FFFFFF"/>
-              </a:gs>
-              <a:gs pos="100000">
-                <a:srgbClr val="F6F6F6"/>
-              </a:gs>
-            </a:gsLst>
-            <a:lin ang="5400000" scaled="1"/>
-          </a:gradFill>
-          <a:ln>
-            <a:noFill/>
-          </a:ln>
-          <a:effectLst>
-            <a:outerShdw blurRad="190500" dist="190500" dir="2700000" algn="tl" rotWithShape="0">
-              <a:schemeClr val="tx1">
-                <a:lumMod val="50000"/>
-                <a:lumOff val="50000"/>
-                <a:alpha val="40000"/>
-              </a:schemeClr>
-            </a:outerShdw>
-          </a:effectLst>
-        </p:spPr>
-        <p:style>
-          <a:lnRef idx="2">
-            <a:schemeClr val="accent1">
-              <a:shade val="15000"/>
-            </a:schemeClr>
-          </a:lnRef>
-          <a:fillRef idx="1">
-            <a:schemeClr val="accent1"/>
-          </a:fillRef>
-          <a:effectRef idx="0">
-            <a:schemeClr val="accent1"/>
-          </a:effectRef>
-          <a:fontRef idx="minor">
-            <a:schemeClr val="lt1"/>
-          </a:fontRef>
-        </p:style>
-        <p:txBody>
-          <a:bodyPr rtlCol="0" anchor="ctr"/>
-          <a:lstStyle/>
-          <a:p>
-            <a:pPr algn="ctr"/>
-            <a:endParaRPr lang="es-CO" sz="1114" dirty="0"/>
-          </a:p>
-        </p:txBody>
-      </p:sp>
-      <p:sp>
-        <p:nvSpPr>
           <p:cNvPr id="1046" name="Rectángulo: esquinas redondeadas 1045">
             <a:extLst>
               <a:ext uri="{FF2B5EF4-FFF2-40B4-BE49-F238E27FC236}">
@@ -4132,8 +3705,8 @@
         </p:nvSpPr>
         <p:spPr>
           <a:xfrm>
-            <a:off x="8819890" y="7261814"/>
-            <a:ext cx="6031404" cy="3499363"/>
+            <a:off x="13639583" y="6045338"/>
+            <a:ext cx="6429746" cy="4715839"/>
           </a:xfrm>
           <a:prstGeom prst="roundRect">
             <a:avLst>
@@ -4899,8 +4472,8 @@
         </p:nvSpPr>
         <p:spPr>
           <a:xfrm>
-            <a:off x="2480830" y="7261814"/>
-            <a:ext cx="6031404" cy="3499363"/>
+            <a:off x="2480829" y="6045338"/>
+            <a:ext cx="10761037" cy="4715839"/>
           </a:xfrm>
           <a:prstGeom prst="roundRect">
             <a:avLst>
@@ -4958,56 +4531,46 @@
       </p:sp>
       <p:pic>
         <p:nvPicPr>
-          <p:cNvPr id="2056" name="Picture 8" descr="Lacoste Logo Download In Hd Quality">
+          <p:cNvPr id="4" name="Imagen 3">
             <a:extLst>
               <a:ext uri="{FF2B5EF4-FFF2-40B4-BE49-F238E27FC236}">
-                <a16:creationId xmlns:a16="http://schemas.microsoft.com/office/drawing/2014/main" id="{D4E033AC-2B88-5CB9-498B-71EEC3404CA9}"/>
+                <a16:creationId xmlns:a16="http://schemas.microsoft.com/office/drawing/2014/main" id="{3DAAA1CC-ABCB-BDD5-2D2D-FFC4FBE907E0}"/>
               </a:ext>
             </a:extLst>
           </p:cNvPr>
           <p:cNvPicPr>
-            <a:picLocks noChangeAspect="1" noChangeArrowheads="1"/>
+            <a:picLocks noChangeAspect="1"/>
           </p:cNvPicPr>
           <p:nvPr/>
         </p:nvPicPr>
         <p:blipFill>
           <a:blip r:embed="rId2">
+            <a:biLevel thresh="25000"/>
             <a:extLst>
               <a:ext uri="{28A0092B-C50C-407E-A947-70E740481C1C}">
                 <a14:useLocalDpi xmlns:a14="http://schemas.microsoft.com/office/drawing/2010/main" val="0"/>
               </a:ext>
             </a:extLst>
           </a:blip>
-          <a:srcRect/>
           <a:stretch>
             <a:fillRect/>
           </a:stretch>
         </p:blipFill>
-        <p:spPr bwMode="auto">
+        <p:spPr>
           <a:xfrm>
-            <a:off x="363758" y="687582"/>
-            <a:ext cx="1612217" cy="775748"/>
+            <a:off x="122874" y="646639"/>
+            <a:ext cx="2093981" cy="867739"/>
           </a:xfrm>
           <a:prstGeom prst="rect">
             <a:avLst/>
           </a:prstGeom>
-          <a:noFill/>
           <a:effectLst>
-            <a:outerShdw blurRad="50800" dist="38100" dir="2700000" algn="tl" rotWithShape="0">
+            <a:glow rad="63500">
               <a:schemeClr val="bg1">
                 <a:alpha val="40000"/>
               </a:schemeClr>
-            </a:outerShdw>
+            </a:glow>
           </a:effectLst>
-          <a:extLst>
-            <a:ext uri="{909E8E84-426E-40DD-AFC4-6F175D3DCCD1}">
-              <a14:hiddenFill xmlns:a14="http://schemas.microsoft.com/office/drawing/2010/main">
-                <a:solidFill>
-                  <a:srgbClr val="FFFFFF"/>
-                </a:solidFill>
-              </a14:hiddenFill>
-            </a:ext>
-          </a:extLst>
         </p:spPr>
       </p:pic>
     </p:spTree>

</xml_diff>